<commit_message>
End of Week 2
</commit_message>
<xml_diff>
--- a/power-apps/wireframes/wireframes-submission-portal.pptx
+++ b/power-apps/wireframes/wireframes-submission-portal.pptx
@@ -126,23 +126,38 @@
 <pc:chgInfo xmlns:a="http://schemas.openxmlformats.org/drawingml/2006/main" xmlns:r="http://schemas.openxmlformats.org/officeDocument/2006/relationships" xmlns:ac="http://schemas.microsoft.com/office/drawing/2013/main/command" xmlns:pc="http://schemas.microsoft.com/office/powerpoint/2013/main/command">
   <pc:docChgLst>
     <pc:chgData name="John Rolzhausen" userId="f0fced98129e348e" providerId="LiveId" clId="{FAB81778-C2AB-48D5-BA9E-3E19BB729E3D}"/>
-    <pc:docChg chg="modSld">
-      <pc:chgData name="John Rolzhausen" userId="f0fced98129e348e" providerId="LiveId" clId="{FAB81778-C2AB-48D5-BA9E-3E19BB729E3D}" dt="2025-11-25T23:06:42.611" v="0" actId="1076"/>
+    <pc:docChg chg="custSel modSld">
+      <pc:chgData name="John Rolzhausen" userId="f0fced98129e348e" providerId="LiveId" clId="{FAB81778-C2AB-48D5-BA9E-3E19BB729E3D}" dt="2025-11-30T00:04:11.650" v="2" actId="478"/>
       <pc:docMkLst>
         <pc:docMk/>
       </pc:docMkLst>
-      <pc:sldChg chg="modSp mod">
-        <pc:chgData name="John Rolzhausen" userId="f0fced98129e348e" providerId="LiveId" clId="{FAB81778-C2AB-48D5-BA9E-3E19BB729E3D}" dt="2025-11-25T23:06:42.611" v="0" actId="1076"/>
+      <pc:sldChg chg="delSp modSp mod">
+        <pc:chgData name="John Rolzhausen" userId="f0fced98129e348e" providerId="LiveId" clId="{FAB81778-C2AB-48D5-BA9E-3E19BB729E3D}" dt="2025-11-29T17:42:54.657" v="1" actId="478"/>
         <pc:sldMkLst>
           <pc:docMk/>
           <pc:sldMk cId="2091095100" sldId="258"/>
         </pc:sldMkLst>
-        <pc:spChg chg="mod">
-          <ac:chgData name="John Rolzhausen" userId="f0fced98129e348e" providerId="LiveId" clId="{FAB81778-C2AB-48D5-BA9E-3E19BB729E3D}" dt="2025-11-25T23:06:42.611" v="0" actId="1076"/>
+        <pc:spChg chg="del mod">
+          <ac:chgData name="John Rolzhausen" userId="f0fced98129e348e" providerId="LiveId" clId="{FAB81778-C2AB-48D5-BA9E-3E19BB729E3D}" dt="2025-11-29T17:42:54.657" v="1" actId="478"/>
           <ac:spMkLst>
             <pc:docMk/>
             <pc:sldMk cId="2091095100" sldId="258"/>
             <ac:spMk id="16" creationId="{8AADB9BC-6A21-0376-7232-6E021F557F7A}"/>
+          </ac:spMkLst>
+        </pc:spChg>
+      </pc:sldChg>
+      <pc:sldChg chg="delSp mod">
+        <pc:chgData name="John Rolzhausen" userId="f0fced98129e348e" providerId="LiveId" clId="{FAB81778-C2AB-48D5-BA9E-3E19BB729E3D}" dt="2025-11-30T00:04:11.650" v="2" actId="478"/>
+        <pc:sldMkLst>
+          <pc:docMk/>
+          <pc:sldMk cId="1979496785" sldId="259"/>
+        </pc:sldMkLst>
+        <pc:spChg chg="del">
+          <ac:chgData name="John Rolzhausen" userId="f0fced98129e348e" providerId="LiveId" clId="{FAB81778-C2AB-48D5-BA9E-3E19BB729E3D}" dt="2025-11-30T00:04:11.650" v="2" actId="478"/>
+          <ac:spMkLst>
+            <pc:docMk/>
+            <pc:sldMk cId="1979496785" sldId="259"/>
+            <ac:spMk id="16" creationId="{D03A5860-1A3D-187C-823D-4A271D63E983}"/>
           </ac:spMkLst>
         </pc:spChg>
       </pc:sldChg>
@@ -233,7 +248,7 @@
           <a:p>
             <a:fld id="{7F571194-8E21-4113-AD09-7A20562102BE}" type="datetimeFigureOut">
               <a:rPr lang="en-US" smtClean="0"/>
-              <a:t>11/25/2025</a:t>
+              <a:t>11/29/2025</a:t>
             </a:fld>
             <a:endParaRPr lang="en-US"/>
           </a:p>
@@ -1740,7 +1755,7 @@
           <a:p>
             <a:fld id="{CDB540FD-1622-4619-B8A4-2E34D7A0DA80}" type="datetimeFigureOut">
               <a:rPr lang="en-US" smtClean="0"/>
-              <a:t>11/25/2025</a:t>
+              <a:t>11/29/2025</a:t>
             </a:fld>
             <a:endParaRPr lang="en-US"/>
           </a:p>
@@ -1938,7 +1953,7 @@
           <a:p>
             <a:fld id="{CDB540FD-1622-4619-B8A4-2E34D7A0DA80}" type="datetimeFigureOut">
               <a:rPr lang="en-US" smtClean="0"/>
-              <a:t>11/25/2025</a:t>
+              <a:t>11/29/2025</a:t>
             </a:fld>
             <a:endParaRPr lang="en-US"/>
           </a:p>
@@ -2146,7 +2161,7 @@
           <a:p>
             <a:fld id="{CDB540FD-1622-4619-B8A4-2E34D7A0DA80}" type="datetimeFigureOut">
               <a:rPr lang="en-US" smtClean="0"/>
-              <a:t>11/25/2025</a:t>
+              <a:t>11/29/2025</a:t>
             </a:fld>
             <a:endParaRPr lang="en-US"/>
           </a:p>
@@ -2344,7 +2359,7 @@
           <a:p>
             <a:fld id="{CDB540FD-1622-4619-B8A4-2E34D7A0DA80}" type="datetimeFigureOut">
               <a:rPr lang="en-US" smtClean="0"/>
-              <a:t>11/25/2025</a:t>
+              <a:t>11/29/2025</a:t>
             </a:fld>
             <a:endParaRPr lang="en-US"/>
           </a:p>
@@ -2619,7 +2634,7 @@
           <a:p>
             <a:fld id="{CDB540FD-1622-4619-B8A4-2E34D7A0DA80}" type="datetimeFigureOut">
               <a:rPr lang="en-US" smtClean="0"/>
-              <a:t>11/25/2025</a:t>
+              <a:t>11/29/2025</a:t>
             </a:fld>
             <a:endParaRPr lang="en-US"/>
           </a:p>
@@ -2884,7 +2899,7 @@
           <a:p>
             <a:fld id="{CDB540FD-1622-4619-B8A4-2E34D7A0DA80}" type="datetimeFigureOut">
               <a:rPr lang="en-US" smtClean="0"/>
-              <a:t>11/25/2025</a:t>
+              <a:t>11/29/2025</a:t>
             </a:fld>
             <a:endParaRPr lang="en-US"/>
           </a:p>
@@ -3296,7 +3311,7 @@
           <a:p>
             <a:fld id="{CDB540FD-1622-4619-B8A4-2E34D7A0DA80}" type="datetimeFigureOut">
               <a:rPr lang="en-US" smtClean="0"/>
-              <a:t>11/25/2025</a:t>
+              <a:t>11/29/2025</a:t>
             </a:fld>
             <a:endParaRPr lang="en-US"/>
           </a:p>
@@ -3437,7 +3452,7 @@
           <a:p>
             <a:fld id="{CDB540FD-1622-4619-B8A4-2E34D7A0DA80}" type="datetimeFigureOut">
               <a:rPr lang="en-US" smtClean="0"/>
-              <a:t>11/25/2025</a:t>
+              <a:t>11/29/2025</a:t>
             </a:fld>
             <a:endParaRPr lang="en-US"/>
           </a:p>
@@ -3550,7 +3565,7 @@
           <a:p>
             <a:fld id="{CDB540FD-1622-4619-B8A4-2E34D7A0DA80}" type="datetimeFigureOut">
               <a:rPr lang="en-US" smtClean="0"/>
-              <a:t>11/25/2025</a:t>
+              <a:t>11/29/2025</a:t>
             </a:fld>
             <a:endParaRPr lang="en-US"/>
           </a:p>
@@ -3861,7 +3876,7 @@
           <a:p>
             <a:fld id="{CDB540FD-1622-4619-B8A4-2E34D7A0DA80}" type="datetimeFigureOut">
               <a:rPr lang="en-US" smtClean="0"/>
-              <a:t>11/25/2025</a:t>
+              <a:t>11/29/2025</a:t>
             </a:fld>
             <a:endParaRPr lang="en-US"/>
           </a:p>
@@ -4149,7 +4164,7 @@
           <a:p>
             <a:fld id="{CDB540FD-1622-4619-B8A4-2E34D7A0DA80}" type="datetimeFigureOut">
               <a:rPr lang="en-US" smtClean="0"/>
-              <a:t>11/25/2025</a:t>
+              <a:t>11/29/2025</a:t>
             </a:fld>
             <a:endParaRPr lang="en-US"/>
           </a:p>
@@ -4390,7 +4405,7 @@
           <a:p>
             <a:fld id="{CDB540FD-1622-4619-B8A4-2E34D7A0DA80}" type="datetimeFigureOut">
               <a:rPr lang="en-US" smtClean="0"/>
-              <a:t>11/25/2025</a:t>
+              <a:t>11/29/2025</a:t>
             </a:fld>
             <a:endParaRPr lang="en-US"/>
           </a:p>
@@ -5421,42 +5436,6 @@
       </p:sp>
       <p:sp>
         <p:nvSpPr>
-          <p:cNvPr id="16" name="TextBox 15">
-            <a:extLst>
-              <a:ext uri="{FF2B5EF4-FFF2-40B4-BE49-F238E27FC236}">
-                <a16:creationId xmlns:a16="http://schemas.microsoft.com/office/drawing/2014/main" id="{8AADB9BC-6A21-0376-7232-6E021F557F7A}"/>
-              </a:ext>
-            </a:extLst>
-          </p:cNvPr>
-          <p:cNvSpPr txBox="1"/>
-          <p:nvPr/>
-        </p:nvSpPr>
-        <p:spPr>
-          <a:xfrm>
-            <a:off x="2215941" y="5547801"/>
-            <a:ext cx="4381503" cy="261610"/>
-          </a:xfrm>
-          <a:prstGeom prst="rect">
-            <a:avLst/>
-          </a:prstGeom>
-          <a:noFill/>
-        </p:spPr>
-        <p:txBody>
-          <a:bodyPr wrap="square" rtlCol="0">
-            <a:spAutoFit/>
-          </a:bodyPr>
-          <a:lstStyle/>
-          <a:p>
-            <a:r>
-              <a:rPr lang="en-US" sz="1100"/>
-              <a:t>First time? Click your name from the dropdown</a:t>
-            </a:r>
-            <a:endParaRPr lang="en-US" sz="1100" dirty="0"/>
-          </a:p>
-        </p:txBody>
-      </p:sp>
-      <p:sp>
-        <p:nvSpPr>
           <p:cNvPr id="8" name="Rectangle 7">
             <a:extLst>
               <a:ext uri="{FF2B5EF4-FFF2-40B4-BE49-F238E27FC236}">
@@ -6163,41 +6142,6 @@
             <a:r>
               <a:rPr lang="en-US" sz="1100" dirty="0"/>
               <a:t>[ ← Back ]    Home &gt; New Submission</a:t>
-            </a:r>
-          </a:p>
-        </p:txBody>
-      </p:sp>
-      <p:sp>
-        <p:nvSpPr>
-          <p:cNvPr id="16" name="TextBox 15">
-            <a:extLst>
-              <a:ext uri="{FF2B5EF4-FFF2-40B4-BE49-F238E27FC236}">
-                <a16:creationId xmlns:a16="http://schemas.microsoft.com/office/drawing/2014/main" id="{D03A5860-1A3D-187C-823D-4A271D63E983}"/>
-              </a:ext>
-            </a:extLst>
-          </p:cNvPr>
-          <p:cNvSpPr txBox="1"/>
-          <p:nvPr/>
-        </p:nvSpPr>
-        <p:spPr>
-          <a:xfrm>
-            <a:off x="691941" y="5560220"/>
-            <a:ext cx="4381503" cy="261610"/>
-          </a:xfrm>
-          <a:prstGeom prst="rect">
-            <a:avLst/>
-          </a:prstGeom>
-          <a:noFill/>
-        </p:spPr>
-        <p:txBody>
-          <a:bodyPr wrap="square" rtlCol="0">
-            <a:spAutoFit/>
-          </a:bodyPr>
-          <a:lstStyle/>
-          <a:p>
-            <a:r>
-              <a:rPr lang="en-US" sz="1100" dirty="0"/>
-              <a:t>Select the month you’re reporting volumes for</a:t>
             </a:r>
           </a:p>
         </p:txBody>

</xml_diff>